<commit_message>
vibration , game design
</commit_message>
<xml_diff>
--- a/MG.pptx
+++ b/MG.pptx
@@ -16569,7 +16569,7 @@
         </p:nvSpPr>
         <p:spPr>
           <a:xfrm>
-            <a:off x="422900" y="540167"/>
+            <a:off x="422900" y="205150"/>
             <a:ext cx="5370576" cy="2135867"/>
           </a:xfrm>
         </p:spPr>
@@ -16580,10 +16580,10 @@
           <a:lstStyle/>
           <a:p>
             <a:r>
-              <a:rPr lang="en-US" sz="4800"/>
+              <a:rPr lang="en-US" sz="4800" dirty="0"/>
               <a:t>Features </a:t>
             </a:r>
-            <a:endParaRPr lang="en-IN" sz="4800"/>
+            <a:endParaRPr lang="en-IN" sz="4800" dirty="0"/>
           </a:p>
         </p:txBody>
       </p:sp>
@@ -16605,16 +16605,21 @@
         </p:nvSpPr>
         <p:spPr>
           <a:xfrm>
-            <a:off x="422900" y="2880452"/>
+            <a:off x="422900" y="2584830"/>
             <a:ext cx="5370576" cy="3095445"/>
           </a:xfrm>
         </p:spPr>
         <p:txBody>
           <a:bodyPr>
-            <a:normAutofit/>
+            <a:normAutofit fontScale="85000" lnSpcReduction="10000"/>
           </a:bodyPr>
           <a:lstStyle/>
           <a:p>
+            <a:pPr>
+              <a:lnSpc>
+                <a:spcPct val="110000"/>
+              </a:lnSpc>
+            </a:pPr>
             <a:r>
               <a:rPr lang="en-US" sz="2000" dirty="0"/>
               <a:t>Currently there are 3 sensors </a:t>
@@ -16622,6 +16627,9 @@
           </a:p>
           <a:p>
             <a:pPr marL="514350" indent="-514350">
+              <a:lnSpc>
+                <a:spcPct val="110000"/>
+              </a:lnSpc>
               <a:buFont typeface="+mj-lt"/>
               <a:buAutoNum type="arabicPeriod"/>
             </a:pPr>
@@ -16632,6 +16640,9 @@
           </a:p>
           <a:p>
             <a:pPr marL="514350" indent="-514350">
+              <a:lnSpc>
+                <a:spcPct val="110000"/>
+              </a:lnSpc>
               <a:buFont typeface="+mj-lt"/>
               <a:buAutoNum type="arabicPeriod"/>
             </a:pPr>
@@ -16642,6 +16653,9 @@
           </a:p>
           <a:p>
             <a:pPr marL="514350" indent="-514350">
+              <a:lnSpc>
+                <a:spcPct val="110000"/>
+              </a:lnSpc>
               <a:buFont typeface="+mj-lt"/>
               <a:buAutoNum type="arabicPeriod"/>
             </a:pPr>
@@ -16651,6 +16665,24 @@
             </a:r>
           </a:p>
           <a:p>
+            <a:pPr marL="514350" indent="-514350">
+              <a:lnSpc>
+                <a:spcPct val="110000"/>
+              </a:lnSpc>
+              <a:buFont typeface="+mj-lt"/>
+              <a:buAutoNum type="arabicPeriod"/>
+            </a:pPr>
+            <a:r>
+              <a:rPr lang="en-US" sz="2000" dirty="0"/>
+              <a:t>Accelerometer – Controls the level of tilt and that controls the movement speed of the ball.</a:t>
+            </a:r>
+          </a:p>
+          <a:p>
+            <a:pPr>
+              <a:lnSpc>
+                <a:spcPct val="110000"/>
+              </a:lnSpc>
+            </a:pPr>
             <a:r>
               <a:rPr lang="en-US" sz="2000" dirty="0"/>
               <a:t>Top Down level with working gyro and Collisions.</a:t>

</xml_diff>